<commit_message>
Add PWA installation guide slide to user guide
</commit_message>
<xml_diff>
--- a/Hiker_App_User_Guide_Updated.pptx
+++ b/Hiker_App_User_Guide_Updated.pptx
@@ -19,6 +19,7 @@
     <p:sldId id="267" r:id="rId18"/>
     <p:sldId id="268" r:id="rId19"/>
     <p:sldId id="269" r:id="rId20"/>
+    <p:sldId id="270" r:id="rId21"/>
   </p:sldIdLst>
   <p:sldSz cx="9144000" cy="6858000" type="screen4x3"/>
   <p:notesSz cx="6858000" cy="9144000"/>
@@ -3626,6 +3627,158 @@
           <a:p>
             <a:r>
               <a:t>• Early start adjusts start time</a:t>
+            </a:r>
+          </a:p>
+        </p:txBody>
+      </p:sp>
+    </p:spTree>
+  </p:cSld>
+  <p:clrMapOvr>
+    <a:masterClrMapping/>
+  </p:clrMapOvr>
+</p:sld>
+</file>
+
+<file path=ppt/slides/slide15.xml><?xml version="1.0" encoding="utf-8"?>
+<p:sld xmlns:a="http://schemas.openxmlformats.org/drawingml/2006/main" xmlns:p="http://schemas.openxmlformats.org/presentationml/2006/main" xmlns:r="http://schemas.openxmlformats.org/officeDocument/2006/relationships">
+  <p:cSld>
+    <p:spTree>
+      <p:nvGrpSpPr>
+        <p:cNvPr id="1" name=""/>
+        <p:cNvGrpSpPr/>
+        <p:nvPr/>
+      </p:nvGrpSpPr>
+      <p:grpSpPr/>
+      <p:sp>
+        <p:nvSpPr>
+          <p:cNvPr id="2" name="Title 1"/>
+          <p:cNvSpPr>
+            <a:spLocks noGrp="1"/>
+          </p:cNvSpPr>
+          <p:nvPr>
+            <p:ph type="title"/>
+          </p:nvPr>
+        </p:nvSpPr>
+        <p:spPr/>
+        <p:txBody>
+          <a:bodyPr/>
+          <a:lstStyle/>
+          <a:p>
+            <a:r>
+              <a:t>Install as a Mobile App (PWA)</a:t>
+            </a:r>
+          </a:p>
+        </p:txBody>
+      </p:sp>
+      <p:sp>
+        <p:nvSpPr>
+          <p:cNvPr id="3" name="Content Placeholder 2"/>
+          <p:cNvSpPr>
+            <a:spLocks noGrp="1"/>
+          </p:cNvSpPr>
+          <p:nvPr>
+            <p:ph idx="1"/>
+          </p:nvPr>
+        </p:nvSpPr>
+        <p:spPr/>
+        <p:txBody>
+          <a:bodyPr/>
+          <a:lstStyle/>
+          <a:p/>
+          <a:p>
+            <a:pPr>
+              <a:defRPr b="1" sz="1800"/>
+            </a:pPr>
+            <a:r>
+              <a:t>Why Install?</a:t>
+            </a:r>
+          </a:p>
+          <a:p>
+            <a:pPr lvl="1">
+              <a:defRPr sz="1600"/>
+            </a:pPr>
+            <a:r>
+              <a:t>Works like a native app - no app store needed</a:t>
+            </a:r>
+          </a:p>
+          <a:p>
+            <a:pPr lvl="1">
+              <a:defRPr sz="1600"/>
+            </a:pPr>
+            <a:r>
+              <a:t>Fast loading, even with slow connections</a:t>
+            </a:r>
+          </a:p>
+          <a:p>
+            <a:pPr lvl="1">
+              <a:defRPr sz="1600"/>
+            </a:pPr>
+            <a:r>
+              <a:t>Shows your app name and icon on the home screen</a:t>
+            </a:r>
+          </a:p>
+          <a:p>
+            <a:pPr>
+              <a:defRPr b="1" sz="1800"/>
+            </a:pPr>
+            <a:r>
+              <a:t>How to Install:</a:t>
+            </a:r>
+          </a:p>
+          <a:p>
+            <a:pPr lvl="1">
+              <a:defRPr sz="1600"/>
+            </a:pPr>
+            <a:r>
+              <a:t>Windows/Android: Open the site in Chrome or Brave, tap the install icon in the address bar</a:t>
+            </a:r>
+          </a:p>
+          <a:p>
+            <a:pPr lvl="1">
+              <a:defRPr sz="1600"/>
+            </a:pPr>
+            <a:r>
+              <a:t>iPhone (Safari): Tap the Share button, then Add to Home Screen</a:t>
+            </a:r>
+          </a:p>
+          <a:p>
+            <a:pPr lvl="1">
+              <a:defRPr sz="1600"/>
+            </a:pPr>
+            <a:r>
+              <a:t>After installing, open it from your home screen like any other app</a:t>
+            </a:r>
+          </a:p>
+          <a:p>
+            <a:pPr>
+              <a:defRPr b="1" sz="1800"/>
+            </a:pPr>
+            <a:r>
+              <a:t>Troubleshooting:</a:t>
+            </a:r>
+          </a:p>
+          <a:p>
+            <a:pPr lvl="1">
+              <a:defRPr sz="1600"/>
+            </a:pPr>
+            <a:r>
+              <a:t>If the name or icon looks wrong, uninstall the old version first</a:t>
+            </a:r>
+          </a:p>
+          <a:p>
+            <a:pPr lvl="1">
+              <a:defRPr sz="1600"/>
+            </a:pPr>
+            <a:r>
+              <a:t>Clear your browser cache if the install prompt does not appear</a:t>
+            </a:r>
+          </a:p>
+          <a:p>
+            <a:pPr lvl="1">
+              <a:defRPr sz="1600"/>
+            </a:pPr>
+            <a:r>
+              <a:t>Make sure you are on the correct URL (e.g. chess4.us/sothh-app/)</a:t>
             </a:r>
           </a:p>
         </p:txBody>

</xml_diff>